<commit_message>
docs: deck v2 — Hebrew app screenshots
Every phone screenshot in the deck is now the Hebrew UI — matches what
Israeli customers actually see and reflects the latest product changes
(centered camera, contact row after selection, Hebrew AI summaries).

New assets:
- docs/screenshots/mockups-he.html — single-source Hebrew mockups,
  mirroring the current production design. Run through any headless
  browser to re-render when the UI evolves.
- docs/screenshots/mock-*-he.png — eight rendered screens: home,
  capture, confirm, my-requests, request-details, selected, whatsapp,
  provider-quote.

Deck content stays in English per investor audience.

Co-Authored-By: Claude Opus 4.7 (1M context) <noreply@anthropic.com>
</commit_message>
<xml_diff>
--- a/docs/investor-deck/ai-fixly-investor-deck.pptx
+++ b/docs/investor-deck/ai-fixly-investor-deck.pptx
@@ -8719,11 +8719,11 @@
         <p:spPr>
           <a:xfrm>
             <a:off x="557784" y="1289304"/>
-            <a:ext cx="1753819" cy="3364992"/>
+            <a:ext cx="1693469" cy="3364992"/>
           </a:xfrm>
           <a:prstGeom prst="roundRect">
             <a:avLst>
-              <a:gd name="adj" fmla="val 11470"/>
+              <a:gd name="adj" fmla="val 11879"/>
             </a:avLst>
           </a:prstGeom>
           <a:solidFill>
@@ -8746,7 +8746,7 @@
       </p:sp>
       <p:pic>
         <p:nvPicPr>
-          <p:cNvPr id="5" name="Image 0" descr="C:\Users\roeea\OneDrive\Documents\Github\ai-fixly\docs\screenshots\mock-home.png">    </p:cNvPr>
+          <p:cNvPr id="5" name="Image 0" descr="C:\Users\roeea\OneDrive\Documents\Github\ai-fixly\.claude\worktrees\agitated-zhukovsky-10d815\docs\screenshots\mock-home-he.png">    </p:cNvPr>
           <p:cNvPicPr>
             <a:picLocks noChangeAspect="1"/>
           </p:cNvPicPr>
@@ -8760,7 +8760,7 @@
         <p:spPr>
           <a:xfrm>
             <a:off x="640080" y="1371600"/>
-            <a:ext cx="1589227" cy="3200400"/>
+            <a:ext cx="1528877" cy="3200400"/>
           </a:xfrm>
           <a:prstGeom prst="rect">
             <a:avLst/>
@@ -9369,11 +9369,11 @@
         <p:spPr>
           <a:xfrm>
             <a:off x="374904" y="1197864"/>
-            <a:ext cx="1753819" cy="3364992"/>
+            <a:ext cx="1693469" cy="3364992"/>
           </a:xfrm>
           <a:prstGeom prst="roundRect">
             <a:avLst>
-              <a:gd name="adj" fmla="val 11470"/>
+              <a:gd name="adj" fmla="val 11879"/>
             </a:avLst>
           </a:prstGeom>
           <a:solidFill>
@@ -9396,7 +9396,7 @@
       </p:sp>
       <p:pic>
         <p:nvPicPr>
-          <p:cNvPr id="4" name="Image 0" descr="C:\Users\roeea\OneDrive\Documents\Github\ai-fixly\docs\screenshots\mock-capture.png">    </p:cNvPr>
+          <p:cNvPr id="4" name="Image 0" descr="C:\Users\roeea\OneDrive\Documents\Github\ai-fixly\.claude\worktrees\agitated-zhukovsky-10d815\docs\screenshots\mock-capture-he.png">    </p:cNvPr>
           <p:cNvPicPr>
             <a:picLocks noChangeAspect="1"/>
           </p:cNvPicPr>
@@ -9410,7 +9410,7 @@
         <p:spPr>
           <a:xfrm>
             <a:off x="457200" y="1280160"/>
-            <a:ext cx="1589227" cy="3200400"/>
+            <a:ext cx="1528877" cy="3200400"/>
           </a:xfrm>
           <a:prstGeom prst="rect">
             <a:avLst/>
@@ -9426,7 +9426,7 @@
         <p:spPr>
           <a:xfrm>
             <a:off x="182880" y="4709160"/>
-            <a:ext cx="2137728" cy="320040"/>
+            <a:ext cx="2077720" cy="320040"/>
           </a:xfrm>
           <a:prstGeom prst="rect">
             <a:avLst/>
@@ -9464,12 +9464,12 @@
         </p:nvSpPr>
         <p:spPr>
           <a:xfrm>
-            <a:off x="3695160" y="1197864"/>
-            <a:ext cx="1753819" cy="3364992"/>
+            <a:off x="3725164" y="1197864"/>
+            <a:ext cx="1693469" cy="3364992"/>
           </a:xfrm>
           <a:prstGeom prst="roundRect">
             <a:avLst>
-              <a:gd name="adj" fmla="val 11470"/>
+              <a:gd name="adj" fmla="val 11879"/>
             </a:avLst>
           </a:prstGeom>
           <a:solidFill>
@@ -9492,7 +9492,7 @@
       </p:sp>
       <p:pic>
         <p:nvPicPr>
-          <p:cNvPr id="7" name="Image 1" descr="C:\Users\roeea\OneDrive\Documents\Github\ai-fixly\docs\screenshots\mock-confirm.png">    </p:cNvPr>
+          <p:cNvPr id="7" name="Image 1" descr="C:\Users\roeea\OneDrive\Documents\Github\ai-fixly\.claude\worktrees\agitated-zhukovsky-10d815\docs\screenshots\mock-confirm-he.png">    </p:cNvPr>
           <p:cNvPicPr>
             <a:picLocks noChangeAspect="1"/>
           </p:cNvPicPr>
@@ -9505,8 +9505,8 @@
         </p:blipFill>
         <p:spPr>
           <a:xfrm>
-            <a:off x="3777456" y="1280160"/>
-            <a:ext cx="1589227" cy="3200400"/>
+            <a:off x="3807460" y="1280160"/>
+            <a:ext cx="1528877" cy="3200400"/>
           </a:xfrm>
           <a:prstGeom prst="rect">
             <a:avLst/>
@@ -9521,8 +9521,8 @@
         </p:nvSpPr>
         <p:spPr>
           <a:xfrm>
-            <a:off x="3503136" y="4709160"/>
-            <a:ext cx="2137728" cy="320040"/>
+            <a:off x="3533140" y="4709160"/>
+            <a:ext cx="2077720" cy="320040"/>
           </a:xfrm>
           <a:prstGeom prst="rect">
             <a:avLst/>
@@ -9560,12 +9560,12 @@
         </p:nvSpPr>
         <p:spPr>
           <a:xfrm>
-            <a:off x="7015417" y="1197864"/>
-            <a:ext cx="1753819" cy="3364992"/>
+            <a:off x="7075424" y="1197864"/>
+            <a:ext cx="1693469" cy="3364992"/>
           </a:xfrm>
           <a:prstGeom prst="roundRect">
             <a:avLst>
-              <a:gd name="adj" fmla="val 11470"/>
+              <a:gd name="adj" fmla="val 11879"/>
             </a:avLst>
           </a:prstGeom>
           <a:solidFill>
@@ -9588,7 +9588,7 @@
       </p:sp>
       <p:pic>
         <p:nvPicPr>
-          <p:cNvPr id="10" name="Image 2" descr="C:\Users\roeea\OneDrive\Documents\Github\ai-fixly\docs\screenshots\mock-request-details.png">    </p:cNvPr>
+          <p:cNvPr id="10" name="Image 2" descr="C:\Users\roeea\OneDrive\Documents\Github\ai-fixly\.claude\worktrees\agitated-zhukovsky-10d815\docs\screenshots\mock-request-details-he.png">    </p:cNvPr>
           <p:cNvPicPr>
             <a:picLocks noChangeAspect="1"/>
           </p:cNvPicPr>
@@ -9601,8 +9601,8 @@
         </p:blipFill>
         <p:spPr>
           <a:xfrm>
-            <a:off x="7097713" y="1280160"/>
-            <a:ext cx="1589227" cy="3200400"/>
+            <a:off x="7157720" y="1280160"/>
+            <a:ext cx="1528877" cy="3200400"/>
           </a:xfrm>
           <a:prstGeom prst="rect">
             <a:avLst/>
@@ -9617,8 +9617,8 @@
         </p:nvSpPr>
         <p:spPr>
           <a:xfrm>
-            <a:off x="6823393" y="4709160"/>
-            <a:ext cx="2137728" cy="320040"/>
+            <a:off x="6883400" y="4709160"/>
+            <a:ext cx="2077720" cy="320040"/>
           </a:xfrm>
           <a:prstGeom prst="rect">
             <a:avLst/>
@@ -9863,11 +9863,11 @@
         <p:spPr>
           <a:xfrm>
             <a:off x="649224" y="1289304"/>
-            <a:ext cx="1753819" cy="3364992"/>
+            <a:ext cx="1693469" cy="3364992"/>
           </a:xfrm>
           <a:prstGeom prst="roundRect">
             <a:avLst>
-              <a:gd name="adj" fmla="val 11470"/>
+              <a:gd name="adj" fmla="val 11879"/>
             </a:avLst>
           </a:prstGeom>
           <a:solidFill>
@@ -9890,7 +9890,7 @@
       </p:sp>
       <p:pic>
         <p:nvPicPr>
-          <p:cNvPr id="5" name="Image 0" descr="C:\Users\roeea\OneDrive\Documents\Github\ai-fixly\docs\screenshots\mock-whatsapp-msg.png">    </p:cNvPr>
+          <p:cNvPr id="5" name="Image 0" descr="C:\Users\roeea\OneDrive\Documents\Github\ai-fixly\.claude\worktrees\agitated-zhukovsky-10d815\docs\screenshots\mock-whatsapp-msg-he.png">    </p:cNvPr>
           <p:cNvPicPr>
             <a:picLocks noChangeAspect="1"/>
           </p:cNvPicPr>
@@ -9904,7 +9904,7 @@
         <p:spPr>
           <a:xfrm>
             <a:off x="731520" y="1371600"/>
-            <a:ext cx="1589227" cy="3200400"/>
+            <a:ext cx="1528877" cy="3200400"/>
           </a:xfrm>
           <a:prstGeom prst="rect">
             <a:avLst/>
@@ -10538,11 +10538,11 @@
         <p:spPr>
           <a:xfrm>
             <a:off x="374904" y="1289304"/>
-            <a:ext cx="1299362" cy="2450592"/>
+            <a:ext cx="1256386" cy="2450592"/>
           </a:xfrm>
           <a:prstGeom prst="roundRect">
             <a:avLst>
-              <a:gd name="adj" fmla="val 15482"/>
+              <a:gd name="adj" fmla="val 16012"/>
             </a:avLst>
           </a:prstGeom>
           <a:solidFill>
@@ -10565,7 +10565,7 @@
       </p:sp>
       <p:pic>
         <p:nvPicPr>
-          <p:cNvPr id="5" name="Image 0" descr="C:\Users\roeea\OneDrive\Documents\Github\ai-fixly\docs\screenshots\mock-home.png">    </p:cNvPr>
+          <p:cNvPr id="5" name="Image 0" descr="C:\Users\roeea\OneDrive\Documents\Github\ai-fixly\.claude\worktrees\agitated-zhukovsky-10d815\docs\screenshots\mock-home-he.png">    </p:cNvPr>
           <p:cNvPicPr>
             <a:picLocks noChangeAspect="1"/>
           </p:cNvPicPr>
@@ -10579,7 +10579,7 @@
         <p:spPr>
           <a:xfrm>
             <a:off x="457200" y="1371600"/>
-            <a:ext cx="1134770" cy="2286000"/>
+            <a:ext cx="1091794" cy="2286000"/>
           </a:xfrm>
           <a:prstGeom prst="rect">
             <a:avLst/>
@@ -10595,7 +10595,7 @@
         <p:spPr>
           <a:xfrm>
             <a:off x="274320" y="3794760"/>
-            <a:ext cx="1500823" cy="274320"/>
+            <a:ext cx="1457960" cy="274320"/>
           </a:xfrm>
           <a:prstGeom prst="rect">
             <a:avLst/>
@@ -10633,12 +10633,12 @@
         </p:nvSpPr>
         <p:spPr>
           <a:xfrm>
-            <a:off x="1793812" y="1289304"/>
-            <a:ext cx="1299362" cy="2450592"/>
+            <a:off x="1802384" y="1289304"/>
+            <a:ext cx="1256386" cy="2450592"/>
           </a:xfrm>
           <a:prstGeom prst="roundRect">
             <a:avLst>
-              <a:gd name="adj" fmla="val 15482"/>
+              <a:gd name="adj" fmla="val 16012"/>
             </a:avLst>
           </a:prstGeom>
           <a:solidFill>
@@ -10661,7 +10661,7 @@
       </p:sp>
       <p:pic>
         <p:nvPicPr>
-          <p:cNvPr id="8" name="Image 1" descr="C:\Users\roeea\OneDrive\Documents\Github\ai-fixly\docs\screenshots\mock-my-requests.png">    </p:cNvPr>
+          <p:cNvPr id="8" name="Image 1" descr="C:\Users\roeea\OneDrive\Documents\Github\ai-fixly\.claude\worktrees\agitated-zhukovsky-10d815\docs\screenshots\mock-my-requests-he.png">    </p:cNvPr>
           <p:cNvPicPr>
             <a:picLocks noChangeAspect="1"/>
           </p:cNvPicPr>
@@ -10674,8 +10674,8 @@
         </p:blipFill>
         <p:spPr>
           <a:xfrm>
-            <a:off x="1876108" y="1371600"/>
-            <a:ext cx="1134770" cy="2286000"/>
+            <a:off x="1884680" y="1371600"/>
+            <a:ext cx="1091794" cy="2286000"/>
           </a:xfrm>
           <a:prstGeom prst="rect">
             <a:avLst/>
@@ -10690,8 +10690,8 @@
         </p:nvSpPr>
         <p:spPr>
           <a:xfrm>
-            <a:off x="1693228" y="3794760"/>
-            <a:ext cx="1500823" cy="274320"/>
+            <a:off x="1701800" y="3794760"/>
+            <a:ext cx="1457960" cy="274320"/>
           </a:xfrm>
           <a:prstGeom prst="rect">
             <a:avLst/>
@@ -10729,12 +10729,12 @@
         </p:nvSpPr>
         <p:spPr>
           <a:xfrm>
-            <a:off x="3212719" y="1289304"/>
-            <a:ext cx="1299362" cy="2450592"/>
+            <a:off x="3229864" y="1289304"/>
+            <a:ext cx="1256386" cy="2450592"/>
           </a:xfrm>
           <a:prstGeom prst="roundRect">
             <a:avLst>
-              <a:gd name="adj" fmla="val 15482"/>
+              <a:gd name="adj" fmla="val 16012"/>
             </a:avLst>
           </a:prstGeom>
           <a:solidFill>
@@ -10757,7 +10757,7 @@
       </p:sp>
       <p:pic>
         <p:nvPicPr>
-          <p:cNvPr id="11" name="Image 2" descr="C:\Users\roeea\OneDrive\Documents\Github\ai-fixly\docs\screenshots\mock-confirm.png">    </p:cNvPr>
+          <p:cNvPr id="11" name="Image 2" descr="C:\Users\roeea\OneDrive\Documents\Github\ai-fixly\.claude\worktrees\agitated-zhukovsky-10d815\docs\screenshots\mock-request-details-he.png">    </p:cNvPr>
           <p:cNvPicPr>
             <a:picLocks noChangeAspect="1"/>
           </p:cNvPicPr>
@@ -10770,8 +10770,8 @@
         </p:blipFill>
         <p:spPr>
           <a:xfrm>
-            <a:off x="3295015" y="1371600"/>
-            <a:ext cx="1134770" cy="2286000"/>
+            <a:off x="3312160" y="1371600"/>
+            <a:ext cx="1091794" cy="2286000"/>
           </a:xfrm>
           <a:prstGeom prst="rect">
             <a:avLst/>
@@ -10786,8 +10786,8 @@
         </p:nvSpPr>
         <p:spPr>
           <a:xfrm>
-            <a:off x="3112135" y="3794760"/>
-            <a:ext cx="1500823" cy="274320"/>
+            <a:off x="3129280" y="3794760"/>
+            <a:ext cx="1457960" cy="274320"/>
           </a:xfrm>
           <a:prstGeom prst="rect">
             <a:avLst/>
@@ -10811,7 +10811,7 @@
                 <a:ea typeface="Calibri" pitchFamily="34" charset="-122"/>
                 <a:cs typeface="Calibri" pitchFamily="34" charset="-120"/>
               </a:rPr>
-              <a:t>AI confirm</a:t>
+              <a:t>Live quotes</a:t>
             </a:r>
             <a:endParaRPr lang="en-US" sz="1000" dirty="0"/>
           </a:p>
@@ -10825,12 +10825,12 @@
         </p:nvSpPr>
         <p:spPr>
           <a:xfrm>
-            <a:off x="4631627" y="1289304"/>
-            <a:ext cx="1299362" cy="2450592"/>
+            <a:off x="4657344" y="1289304"/>
+            <a:ext cx="1256386" cy="2450592"/>
           </a:xfrm>
           <a:prstGeom prst="roundRect">
             <a:avLst>
-              <a:gd name="adj" fmla="val 15482"/>
+              <a:gd name="adj" fmla="val 16012"/>
             </a:avLst>
           </a:prstGeom>
           <a:solidFill>
@@ -10853,7 +10853,7 @@
       </p:sp>
       <p:pic>
         <p:nvPicPr>
-          <p:cNvPr id="14" name="Image 3" descr="C:\Users\roeea\OneDrive\Documents\Github\ai-fixly\docs\screenshots\mock-selected.png">    </p:cNvPr>
+          <p:cNvPr id="14" name="Image 3" descr="C:\Users\roeea\OneDrive\Documents\Github\ai-fixly\.claude\worktrees\agitated-zhukovsky-10d815\docs\screenshots\mock-selected-he.png">    </p:cNvPr>
           <p:cNvPicPr>
             <a:picLocks noChangeAspect="1"/>
           </p:cNvPicPr>
@@ -10866,8 +10866,8 @@
         </p:blipFill>
         <p:spPr>
           <a:xfrm>
-            <a:off x="4713923" y="1371600"/>
-            <a:ext cx="1134770" cy="2286000"/>
+            <a:off x="4739640" y="1371600"/>
+            <a:ext cx="1091794" cy="2286000"/>
           </a:xfrm>
           <a:prstGeom prst="rect">
             <a:avLst/>
@@ -10882,8 +10882,8 @@
         </p:nvSpPr>
         <p:spPr>
           <a:xfrm>
-            <a:off x="4531043" y="3794760"/>
-            <a:ext cx="1500823" cy="274320"/>
+            <a:off x="4556760" y="3794760"/>
+            <a:ext cx="1457960" cy="274320"/>
           </a:xfrm>
           <a:prstGeom prst="rect">
             <a:avLst/>
@@ -10921,12 +10921,12 @@
         </p:nvSpPr>
         <p:spPr>
           <a:xfrm>
-            <a:off x="6050534" y="1289304"/>
-            <a:ext cx="1299362" cy="2450592"/>
+            <a:off x="6084824" y="1289304"/>
+            <a:ext cx="1256386" cy="2450592"/>
           </a:xfrm>
           <a:prstGeom prst="roundRect">
             <a:avLst>
-              <a:gd name="adj" fmla="val 15482"/>
+              <a:gd name="adj" fmla="val 16012"/>
             </a:avLst>
           </a:prstGeom>
           <a:solidFill>
@@ -10949,7 +10949,7 @@
       </p:sp>
       <p:pic>
         <p:nvPicPr>
-          <p:cNvPr id="17" name="Image 4" descr="C:\Users\roeea\OneDrive\Documents\Github\ai-fixly\docs\screenshots\mock-provider-quote.png">    </p:cNvPr>
+          <p:cNvPr id="17" name="Image 4" descr="C:\Users\roeea\OneDrive\Documents\Github\ai-fixly\.claude\worktrees\agitated-zhukovsky-10d815\docs\screenshots\mock-whatsapp-msg-he.png">    </p:cNvPr>
           <p:cNvPicPr>
             <a:picLocks noChangeAspect="1"/>
           </p:cNvPicPr>
@@ -10962,8 +10962,8 @@
         </p:blipFill>
         <p:spPr>
           <a:xfrm>
-            <a:off x="6132830" y="1371600"/>
-            <a:ext cx="1134770" cy="2286000"/>
+            <a:off x="6167120" y="1371600"/>
+            <a:ext cx="1091794" cy="2286000"/>
           </a:xfrm>
           <a:prstGeom prst="rect">
             <a:avLst/>
@@ -10978,8 +10978,8 @@
         </p:nvSpPr>
         <p:spPr>
           <a:xfrm>
-            <a:off x="5949950" y="3794760"/>
-            <a:ext cx="1500823" cy="274320"/>
+            <a:off x="5984240" y="3794760"/>
+            <a:ext cx="1457960" cy="274320"/>
           </a:xfrm>
           <a:prstGeom prst="rect">
             <a:avLst/>
@@ -11003,7 +11003,7 @@
                 <a:ea typeface="Calibri" pitchFamily="34" charset="-122"/>
                 <a:cs typeface="Calibri" pitchFamily="34" charset="-120"/>
               </a:rPr>
-              <a:t>Pro quote form</a:t>
+              <a:t>Provider DM</a:t>
             </a:r>
             <a:endParaRPr lang="en-US" sz="1000" dirty="0"/>
           </a:p>
@@ -11017,12 +11017,12 @@
         </p:nvSpPr>
         <p:spPr>
           <a:xfrm>
-            <a:off x="7469442" y="1289304"/>
-            <a:ext cx="1299362" cy="2450592"/>
+            <a:off x="7512304" y="1289304"/>
+            <a:ext cx="1256386" cy="2450592"/>
           </a:xfrm>
           <a:prstGeom prst="roundRect">
             <a:avLst>
-              <a:gd name="adj" fmla="val 15482"/>
+              <a:gd name="adj" fmla="val 16012"/>
             </a:avLst>
           </a:prstGeom>
           <a:solidFill>
@@ -11045,7 +11045,7 @@
       </p:sp>
       <p:pic>
         <p:nvPicPr>
-          <p:cNvPr id="20" name="Image 5" descr="C:\Users\roeea\OneDrive\Documents\Github\ai-fixly\docs\screenshots\mock-review.png">    </p:cNvPr>
+          <p:cNvPr id="20" name="Image 5" descr="C:\Users\roeea\OneDrive\Documents\Github\ai-fixly\.claude\worktrees\agitated-zhukovsky-10d815\docs\screenshots\mock-provider-quote-he.png">    </p:cNvPr>
           <p:cNvPicPr>
             <a:picLocks noChangeAspect="1"/>
           </p:cNvPicPr>
@@ -11058,8 +11058,8 @@
         </p:blipFill>
         <p:spPr>
           <a:xfrm>
-            <a:off x="7551738" y="1371600"/>
-            <a:ext cx="1134770" cy="2286000"/>
+            <a:off x="7594600" y="1371600"/>
+            <a:ext cx="1091794" cy="2286000"/>
           </a:xfrm>
           <a:prstGeom prst="rect">
             <a:avLst/>
@@ -11074,8 +11074,8 @@
         </p:nvSpPr>
         <p:spPr>
           <a:xfrm>
-            <a:off x="7368858" y="3794760"/>
-            <a:ext cx="1500823" cy="274320"/>
+            <a:off x="7411720" y="3794760"/>
+            <a:ext cx="1457960" cy="274320"/>
           </a:xfrm>
           <a:prstGeom prst="rect">
             <a:avLst/>
@@ -11099,7 +11099,7 @@
                 <a:ea typeface="Calibri" pitchFamily="34" charset="-122"/>
                 <a:cs typeface="Calibri" pitchFamily="34" charset="-120"/>
               </a:rPr>
-              <a:t>Review + rating</a:t>
+              <a:t>Pro quote form</a:t>
             </a:r>
             <a:endParaRPr lang="en-US" sz="1000" dirty="0"/>
           </a:p>

</xml_diff>